<commit_message>
docs: complete finals presentation v2 with visual QA
by Sofia Yan & Omni
</commit_message>
<xml_diff>
--- a/final-deck/從碳客變捷客_決賽簡報_v2.pptx
+++ b/final-deck/從碳客變捷客_決賽簡報_v2.pptx
@@ -7200,8 +7200,8 @@
         </p:nvSpPr>
         <p:spPr>
           <a:xfrm>
-            <a:off x="4023360" y="2331720"/>
-            <a:ext cx="320040" cy="548640"/>
+            <a:off x="4023360" y="2286000"/>
+            <a:ext cx="365760" cy="731520"/>
           </a:xfrm>
           <a:prstGeom prst="rect">
             <a:avLst/>
@@ -7223,7 +7223,7 @@
               </a:spcAft>
             </a:pPr>
             <a:r>
-              <a:rPr sz="2000" b="1">
+              <a:rPr sz="1800" b="1">
                 <a:solidFill>
                   <a:srgbClr val="17231C"/>
                 </a:solidFill>
@@ -7531,8 +7531,8 @@
         </p:nvSpPr>
         <p:spPr>
           <a:xfrm>
-            <a:off x="7845552" y="2331720"/>
-            <a:ext cx="320040" cy="548640"/>
+            <a:off x="7845552" y="2286000"/>
+            <a:ext cx="365760" cy="731520"/>
           </a:xfrm>
           <a:prstGeom prst="rect">
             <a:avLst/>
@@ -7554,7 +7554,7 @@
               </a:spcAft>
             </a:pPr>
             <a:r>
-              <a:rPr sz="2000" b="1">
+              <a:rPr sz="1800" b="1">
                 <a:solidFill>
                   <a:srgbClr val="17231C"/>
                 </a:solidFill>
@@ -9559,8 +9559,8 @@
         </p:nvSpPr>
         <p:spPr>
           <a:xfrm>
-            <a:off x="557784" y="6089903"/>
-            <a:ext cx="11155680" cy="502920"/>
+            <a:off x="557784" y="5998464"/>
+            <a:ext cx="11155680" cy="457200"/>
           </a:xfrm>
           <a:prstGeom prst="roundRect">
             <a:avLst>
@@ -9605,8 +9605,8 @@
         </p:nvSpPr>
         <p:spPr>
           <a:xfrm>
-            <a:off x="502920" y="6035040"/>
-            <a:ext cx="11155680" cy="502920"/>
+            <a:off x="502920" y="5943600"/>
+            <a:ext cx="11155680" cy="457200"/>
           </a:xfrm>
           <a:prstGeom prst="roundRect">
             <a:avLst>
@@ -14580,7 +14580,7 @@
                 <a:latin typeface="微軟正黑體"/>
                 <a:ea typeface="微軟正黑體"/>
               </a:rPr>
-              <a:t>決賽 10 強都在發點數 — 只有我們做「可驗證的減碳資產」</a:t>
+              <a:t>10 強都在發點數，只有我們做可驗證的減碳資產</a:t>
             </a:r>
           </a:p>
         </p:txBody>
@@ -17231,8 +17231,8 @@
         </p:nvSpPr>
         <p:spPr>
           <a:xfrm>
-            <a:off x="2743200" y="5285232"/>
-            <a:ext cx="320040" cy="548640"/>
+            <a:off x="2724912" y="5257800"/>
+            <a:ext cx="365760" cy="685800"/>
           </a:xfrm>
           <a:prstGeom prst="rect">
             <a:avLst/>
@@ -17254,7 +17254,7 @@
               </a:spcAft>
             </a:pPr>
             <a:r>
-              <a:rPr sz="1800" b="1">
+              <a:rPr sz="1600" b="1">
                 <a:solidFill>
                   <a:srgbClr val="17231C"/>
                 </a:solidFill>
@@ -17385,8 +17385,8 @@
         </p:nvSpPr>
         <p:spPr>
           <a:xfrm>
-            <a:off x="4956048" y="5285232"/>
-            <a:ext cx="320040" cy="548640"/>
+            <a:off x="4937760" y="5257800"/>
+            <a:ext cx="365760" cy="685800"/>
           </a:xfrm>
           <a:prstGeom prst="rect">
             <a:avLst/>
@@ -17408,7 +17408,7 @@
               </a:spcAft>
             </a:pPr>
             <a:r>
-              <a:rPr sz="1800" b="1">
+              <a:rPr sz="1600" b="1">
                 <a:solidFill>
                   <a:srgbClr val="17231C"/>
                 </a:solidFill>
@@ -17539,8 +17539,8 @@
         </p:nvSpPr>
         <p:spPr>
           <a:xfrm>
-            <a:off x="7168896" y="5285232"/>
-            <a:ext cx="320040" cy="548640"/>
+            <a:off x="7150608" y="5257800"/>
+            <a:ext cx="365760" cy="685800"/>
           </a:xfrm>
           <a:prstGeom prst="rect">
             <a:avLst/>
@@ -17562,7 +17562,7 @@
               </a:spcAft>
             </a:pPr>
             <a:r>
-              <a:rPr sz="1800" b="1">
+              <a:rPr sz="1600" b="1">
                 <a:solidFill>
                   <a:srgbClr val="17231C"/>
                 </a:solidFill>
@@ -17693,8 +17693,8 @@
         </p:nvSpPr>
         <p:spPr>
           <a:xfrm>
-            <a:off x="9381744" y="5285232"/>
-            <a:ext cx="320040" cy="548640"/>
+            <a:off x="9363456" y="5257800"/>
+            <a:ext cx="365760" cy="685800"/>
           </a:xfrm>
           <a:prstGeom prst="rect">
             <a:avLst/>
@@ -17716,7 +17716,7 @@
               </a:spcAft>
             </a:pPr>
             <a:r>
-              <a:rPr sz="1800" b="1">
+              <a:rPr sz="1600" b="1">
                 <a:solidFill>
                   <a:srgbClr val="17231C"/>
                 </a:solidFill>

</xml_diff>